<commit_message>
docs: update deck for the second design
</commit_message>
<xml_diff>
--- a/docs/presentation/TriageGPT_deck.pptx
+++ b/docs/presentation/TriageGPT_deck.pptx
@@ -114,25 +114,25 @@
   <p:extLst>
     <p:ext uri="{521415D9-36F7-43E2-AB2F-B90AF26B5E84}">
       <p14:sectionLst xmlns:p14="http://schemas.microsoft.com/office/powerpoint/2010/main">
-        <p14:section name="Intro" id="{bf536373-b40f-e8f1-192b-6551fece773f}">
+        <p14:section name="Intro" id="{9fd5074b-6662-b40b-aafd-8598aff14ccd}">
           <p14:sldIdLst>
             <p14:sldId id="256"/>
             <p14:sldId id="257"/>
           </p14:sldIdLst>
         </p14:section>
-        <p14:section name="Demo and design" id="{d8979ab1-7fe5-e30b-a7d4-d2da4f987511}">
+        <p14:section name="Demo and design" id="{31bd753d-b210-4a14-eebd-40f1890a155c}">
           <p14:sldIdLst>
             <p14:sldId id="258"/>
             <p14:sldId id="259"/>
           </p14:sldIdLst>
         </p14:section>
-        <p14:section name="Results" id="{97575eed-0ddb-8c1e-b74f-1b8eae699852}">
+        <p14:section name="Results" id="{e20e48dc-d4f5-93c0-19eb-9cfab8f3f282}">
           <p14:sldIdLst>
             <p14:sldId id="260"/>
             <p14:sldId id="261"/>
           </p14:sldIdLst>
         </p14:section>
-        <p14:section name="Close" id="{4764adbc-b4fd-1d8a-dd56-9ab1cbef8b93}">
+        <p14:section name="Close" id="{33cf2afd-a1ff-d7e1-5608-88925293d2eb}">
           <p14:sldIdLst>
             <p14:sldId id="262"/>
             <p14:sldId id="263"/>
@@ -544,7 +544,7 @@
                 </a:solidFill>
                 <a:latin typeface="+mn-lt"/>
               </a:rPr>
-              <a:t>Answer / ask / refuse decisions correct (%)</a:t>
+              <a:t>Answer / ask / refuse decisions correct on unseen questions (%)</a:t>
             </a:r>
           </a:p>
         </c:rich>
@@ -611,10 +611,10 @@
                 <c:ptCount val="2"/>
                 <c:lvl>
                   <c:pt idx="0">
-                    <c:v>Tuned set (52 questions)</c:v>
+                    <c:v>First design, 24 unseen</c:v>
                   </c:pt>
                   <c:pt idx="1">
-                    <c:v>Held-out set (24 questions)</c:v>
+                    <c:v>Second design, 44 sealed (run once)</c:v>
                   </c:pt>
                 </c:lvl>
               </c:multiLvlStrCache>
@@ -627,10 +627,10 @@
                 <c:formatCode>General</c:formatCode>
                 <c:ptCount val="2"/>
                 <c:pt idx="0">
-                  <c:v>94.2</c:v>
+                  <c:v>75</c:v>
                 </c:pt>
                 <c:pt idx="1">
-                  <c:v>75</c:v>
+                  <c:v>88.6</c:v>
                 </c:pt>
               </c:numCache>
             </c:numRef>
@@ -1618,7 +1618,7 @@
           <a:p>
             <a:r>
               <a:rPr lang="en-US" dirty="0"/>
-              <a:t>I chose the thresholds by reading scores off the 52-question set, so its 96.2% is in-sample. I wrote the 24 held-out questions afterwards and never tuned on them. The drop is mostly cases where it asked for more information when it could have answered: the safe way to be wrong.</a:t>
+              <a:t>The first design scored 94-96% on the questions it was tuned on and 75% on 24 new ones. One live question exposed three faults: the gate read the wrong entry's score, the badge contradicted the answer, and escalations were incomplete. I fixed those, wrote 44 new questions before changing anything, froze the code and ran them once: 88.6%. The two sets differ in size and content, so this is not a like-for-like comparison. The sealed set is now spent.</a:t>
             </a:r>
             <a:endParaRPr lang="en-US" dirty="0"/>
           </a:p>
@@ -4169,7 +4169,7 @@
                   <a:schemeClr val="tx1"/>
                 </a:solidFill>
               </a:rPr>
-              <a:t>Gate: answer, ask, or refuse</a:t>
+              <a:t>Gate: refuse, confident, or uncertain</a:t>
             </a:r>
             <a:endParaRPr lang="en-US" sz="1500" dirty="0"/>
           </a:p>
@@ -4517,7 +4517,7 @@
                   <a:schemeClr val="tx1"/>
                 </a:solidFill>
               </a:rPr>
-              <a:t>Low confidence: the model is never called. Medium: it asks questions. High: it writes up the answer.</a:t>
+              <a:t>Nothing close: the model is never called. Confident: it writes up the answer. Uncertain: it chooses to answer, ask, or refuse.</a:t>
             </a:r>
             <a:endParaRPr lang="en-US" sz="1600" dirty="0"/>
           </a:p>
@@ -4939,7 +4939,7 @@
                   <a:schemeClr val="tx2"/>
                 </a:solidFill>
               </a:rPr>
-              <a:t>Trust the held-out score, not the tuned one</a:t>
+              <a:t>Unseen questions: 75% before, 88.6% after the fixes</a:t>
             </a:r>
             <a:endParaRPr lang="en-US" sz="3400" dirty="0"/>
           </a:p>
@@ -5057,7 +5057,7 @@
                   <a:schemeClr val="tx1"/>
                 </a:solidFill>
               </a:rPr>
-              <a:t>out-of-scope questions wrongly answered, on both sets</a:t>
+              <a:t>out-of-scope questions wrongly answered, on every set</a:t>
             </a:r>
             <a:endParaRPr lang="en-US" sz="1500" dirty="0"/>
           </a:p>
@@ -5123,7 +5123,7 @@
                 <a:ea typeface="Cambria" pitchFamily="34" charset="-122"/>
                 <a:cs typeface="Cambria" pitchFamily="34" charset="-120"/>
               </a:rPr>
-              <a:t>98.3%</a:t>
+              <a:t>100%</a:t>
             </a:r>
             <a:endParaRPr lang="en-US" sz="3600" dirty="0"/>
           </a:p>
@@ -5159,7 +5159,7 @@
                   <a:schemeClr val="tx1"/>
                 </a:solidFill>
               </a:rPr>
-              <a:t>of statements supported by a judge model (held-out)</a:t>
+              <a:t>of 260 statements supported by a judge model (sealed set)</a:t>
             </a:r>
             <a:endParaRPr lang="en-US" sz="1500" dirty="0"/>
           </a:p>
@@ -5225,7 +5225,7 @@
                 <a:ea typeface="Cambria" pitchFamily="34" charset="-122"/>
                 <a:cs typeface="Cambria" pitchFamily="34" charset="-120"/>
               </a:rPr>
-              <a:t>2.6 s</a:t>
+              <a:t>2.5 s</a:t>
             </a:r>
             <a:endParaRPr lang="en-US" sz="3600" dirty="0"/>
           </a:p>
@@ -5261,7 +5261,7 @@
                   <a:schemeClr val="tx1"/>
                 </a:solidFill>
               </a:rPr>
-              <a:t>median response time, p95 4.4 s</a:t>
+              <a:t>median response time, p95 6.9 s</a:t>
             </a:r>
             <a:endParaRPr lang="en-US" sz="1500" dirty="0"/>
           </a:p>
@@ -5435,7 +5435,7 @@
                 <a:ea typeface="Cambria" pitchFamily="34" charset="-122"/>
                 <a:cs typeface="Cambria" pitchFamily="34" charset="-120"/>
               </a:rPr>
-              <a:t>Too cautious on mixed paraphrases</a:t>
+              <a:t>Short vague messages</a:t>
             </a:r>
             <a:endParaRPr lang="en-US" sz="2000" dirty="0"/>
           </a:p>
@@ -5471,7 +5471,7 @@
                   <a:schemeClr val="tx1"/>
                 </a:solidFill>
               </a:rPr>
-              <a:t>3 of 14 answerable held-out questions got "need more info" although the right entry was found.</a:t>
+              <a:t>3 of 5 vague sealed questions ("the system seems down") were told "not in KB" instead of being asked what is wrong.</a:t>
             </a:r>
             <a:endParaRPr lang="en-US" sz="1600" dirty="0"/>
           </a:p>
@@ -5537,7 +5537,7 @@
                 <a:ea typeface="Cambria" pitchFamily="34" charset="-122"/>
                 <a:cs typeface="Cambria" pitchFamily="34" charset="-120"/>
               </a:rPr>
-              <a:t>Model can over-refuse</a:t>
+              <a:t>The model can still over-refuse</a:t>
             </a:r>
             <a:endParaRPr lang="en-US" sz="2000" dirty="0"/>
           </a:p>
@@ -5573,7 +5573,7 @@
                   <a:schemeClr val="tx1"/>
                 </a:solidFill>
               </a:rPr>
-              <a:t>One terminal-offline question was told "not in KB" even though the KB covers it.</a:t>
+              <a:t>A KEY_REVOKED question was judged outside the KB, although the KB covers it.</a:t>
             </a:r>
             <a:endParaRPr lang="en-US" sz="1600" dirty="0"/>
           </a:p>
@@ -5639,7 +5639,7 @@
                 <a:ea typeface="Cambria" pitchFamily="34" charset="-122"/>
                 <a:cs typeface="Cambria" pitchFamily="34" charset="-120"/>
               </a:rPr>
-              <a:t>Shared vocabulary</a:t>
+              <a:t>Free-tier limits</a:t>
             </a:r>
             <a:endParaRPr lang="en-US" sz="2000" dirty="0"/>
           </a:p>
@@ -5675,7 +5675,7 @@
                   <a:schemeClr val="tx1"/>
                 </a:solidFill>
               </a:rPr>
-              <a:t>"Printer at the office" is out of scope but got a clarifying question, not a flat refusal.</a:t>
+              <a:t>Daily token limits ran out twice during evaluation, so different runs used different models.</a:t>
             </a:r>
             <a:endParaRPr lang="en-US" sz="1600" dirty="0"/>
           </a:p>
@@ -5777,7 +5777,7 @@
                   <a:schemeClr val="tx1"/>
                 </a:solidFill>
               </a:rPr>
-              <a:t>52 + 24 questions written by one person; the judge is itself a model.</a:t>
+              <a:t>Sets of 24-52 questions by one person; the sealed set is spent; the judge is itself a model.</a:t>
             </a:r>
             <a:endParaRPr lang="en-US" sz="1600" dirty="0"/>
           </a:p>

</xml_diff>